<commit_message>
docs: rebuild the deck from live metadata with product screenshots
</commit_message>
<xml_diff>
--- a/docs/deck.pptx
+++ b/docs/deck.pptx
@@ -3092,7 +3092,7 @@
     <p:bg>
       <p:bgPr>
         <a:solidFill>
-          <a:srgbClr val="FAF9F6"/>
+          <a:srgbClr val="F6F6F3"/>
         </a:solidFill>
         <a:effectLst/>
       </p:bgPr>
@@ -3132,11 +3132,11 @@
               </a:spcAft>
             </a:pPr>
             <a:r>
-              <a:rPr sz="1100" b="0">
-                <a:solidFill>
-                  <a:srgbClr val="7D7767"/>
-                </a:solidFill>
-                <a:latin typeface="IBM Plex Mono"/>
+              <a:rPr sz="1100" b="1">
+                <a:solidFill>
+                  <a:srgbClr val="0B5D4B"/>
+                </a:solidFill>
+                <a:latin typeface="Arial"/>
               </a:rPr>
               <a:t>BANO QABIL AI HACKATHON</a:t>
             </a:r>
@@ -3151,7 +3151,7 @@
         </p:nvSpPr>
         <p:spPr>
           <a:xfrm>
-            <a:off x="777240" y="960120"/>
+            <a:off x="777240" y="914400"/>
             <a:ext cx="10607040" cy="914400"/>
           </a:xfrm>
           <a:prstGeom prst="rect">
@@ -3171,11 +3171,11 @@
               </a:spcAft>
             </a:pPr>
             <a:r>
-              <a:rPr sz="3800" b="0">
-                <a:solidFill>
-                  <a:srgbClr val="17150F"/>
-                </a:solidFill>
-                <a:latin typeface="Newsreader"/>
+              <a:rPr sz="4000" b="0">
+                <a:solidFill>
+                  <a:srgbClr val="0E1412"/>
+                </a:solidFill>
+                <a:latin typeface="Georgia"/>
               </a:rPr>
               <a:t>Claim Check</a:t>
             </a:r>
@@ -3198,7 +3198,7 @@
           </a:prstGeom>
           <a:ln w="9525">
             <a:solidFill>
-              <a:srgbClr val="E2DED2"/>
+              <a:srgbClr val="E1E3DD"/>
             </a:solidFill>
           </a:ln>
         </p:spPr>
@@ -3225,8 +3225,8 @@
         </p:nvSpPr>
         <p:spPr>
           <a:xfrm>
-            <a:off x="822960" y="2286000"/>
-            <a:ext cx="6949440" cy="3291840"/>
+            <a:off x="822960" y="2240280"/>
+            <a:ext cx="5120640" cy="3566160"/>
           </a:xfrm>
           <a:prstGeom prst="rect">
             <a:avLst/>
@@ -3245,13 +3245,13 @@
               </a:spcAft>
             </a:pPr>
             <a:r>
-              <a:rPr sz="1500">
-                <a:solidFill>
-                  <a:srgbClr val="4A463B"/>
-                </a:solidFill>
-                <a:latin typeface="IBM Plex Sans"/>
-              </a:rPr>
-              <a:t>A spell-checker for insurance claims.</a:t>
+              <a:rPr sz="1400">
+                <a:solidFill>
+                  <a:srgbClr val="3E4945"/>
+                </a:solidFill>
+                <a:latin typeface="Arial"/>
+              </a:rPr>
+              <a:t>Catch the rejection before you submit the claim.</a:t>
             </a:r>
           </a:p>
           <a:p>
@@ -3260,15 +3260,6 @@
                 <a:spcPts val="300"/>
               </a:spcAft>
             </a:pPr>
-            <a:r>
-              <a:rPr sz="1500">
-                <a:solidFill>
-                  <a:srgbClr val="4A463B"/>
-                </a:solidFill>
-                <a:latin typeface="IBM Plex Sans"/>
-              </a:rPr>
-              <a:t>Checks a clinic's claim before it is submitted: how likely it is to be</a:t>
-            </a:r>
           </a:p>
           <a:p>
             <a:pPr>
@@ -3277,26 +3268,50 @@
               </a:spcAft>
             </a:pPr>
             <a:r>
-              <a:rPr sz="1500">
-                <a:solidFill>
-                  <a:srgbClr val="4A463B"/>
-                </a:solidFill>
-                <a:latin typeface="IBM Plex Sans"/>
-              </a:rPr>
-              <a:t>rejected, which field is the problem, and what to fix.</a:t>
-            </a:r>
-          </a:p>
-        </p:txBody>
-      </p:sp>
-      <p:sp>
-        <p:nvSpPr>
-          <p:cNvPr id="6" name="TextBox 5"/>
+              <a:rPr sz="1400">
+                <a:solidFill>
+                  <a:srgbClr val="3E4945"/>
+                </a:solidFill>
+                <a:latin typeface="Arial"/>
+              </a:rPr>
+              <a:t>A pre-submission check for Pakistani private clinics: how likely a claim is to be rejected, which field is the problem, and what to fix.</a:t>
+            </a:r>
+          </a:p>
+        </p:txBody>
+      </p:sp>
+      <p:pic>
+        <p:nvPicPr>
+          <p:cNvPr id="6" name="Picture 5" descr="landing.png"/>
+          <p:cNvPicPr>
+            <a:picLocks noChangeAspect="1"/>
+          </p:cNvPicPr>
+          <p:nvPr/>
+        </p:nvPicPr>
+        <p:blipFill>
+          <a:blip r:embed="rId2"/>
+          <a:stretch>
+            <a:fillRect/>
+          </a:stretch>
+        </p:blipFill>
+        <p:spPr>
+          <a:xfrm>
+            <a:off x="6263640" y="2240280"/>
+            <a:ext cx="5120640" cy="3200400"/>
+          </a:xfrm>
+          <a:prstGeom prst="rect">
+            <a:avLst/>
+          </a:prstGeom>
+        </p:spPr>
+      </p:pic>
+      <p:sp>
+        <p:nvSpPr>
+          <p:cNvPr id="7" name="TextBox 6"/>
           <p:cNvSpPr txBox="1"/>
           <p:nvPr/>
         </p:nvSpPr>
         <p:spPr>
           <a:xfrm>
-            <a:off x="822960" y="6035040"/>
+            <a:off x="822960" y="6080760"/>
             <a:ext cx="10515600" cy="365760"/>
           </a:xfrm>
           <a:prstGeom prst="rect">
@@ -3318,24 +3333,24 @@
             <a:r>
               <a:rPr sz="1100" b="0">
                 <a:solidFill>
-                  <a:srgbClr val="7D7767"/>
-                </a:solidFill>
-                <a:latin typeface="IBM Plex Mono"/>
-              </a:rPr>
-              <a:t>Mirza Ahsan Baig and Safee Akmal · LightGBM + SHAP + Qwen on DashScope</a:t>
-            </a:r>
-          </a:p>
-        </p:txBody>
-      </p:sp>
-      <p:sp>
-        <p:nvSpPr>
-          <p:cNvPr id="7" name="TextBox 6"/>
+                  <a:srgbClr val="5F6A66"/>
+                </a:solidFill>
+                <a:latin typeface="Arial"/>
+              </a:rPr>
+              <a:t>Mirza Ahsan Baig and Safee Akmal · Tasdeeq-e-Bima</a:t>
+            </a:r>
+          </a:p>
+        </p:txBody>
+      </p:sp>
+      <p:sp>
+        <p:nvSpPr>
+          <p:cNvPr id="8" name="TextBox 7"/>
           <p:cNvSpPr txBox="1"/>
           <p:nvPr/>
         </p:nvSpPr>
         <p:spPr>
           <a:xfrm>
-            <a:off x="11247120" y="6035040"/>
+            <a:off x="11247120" y="6080760"/>
             <a:ext cx="548640" cy="365760"/>
           </a:xfrm>
           <a:prstGeom prst="rect">
@@ -3357,9 +3372,9 @@
             <a:r>
               <a:rPr sz="1100" b="0">
                 <a:solidFill>
-                  <a:srgbClr val="7D7767"/>
-                </a:solidFill>
-                <a:latin typeface="IBM Plex Mono"/>
+                  <a:srgbClr val="5F6A66"/>
+                </a:solidFill>
+                <a:latin typeface="Arial"/>
               </a:rPr>
               <a:t>1</a:t>
             </a:r>
@@ -3380,7 +3395,7 @@
     <p:bg>
       <p:bgPr>
         <a:solidFill>
-          <a:srgbClr val="FAF9F6"/>
+          <a:srgbClr val="F6F6F3"/>
         </a:solidFill>
         <a:effectLst/>
       </p:bgPr>
@@ -3420,11 +3435,11 @@
               </a:spcAft>
             </a:pPr>
             <a:r>
-              <a:rPr sz="1100" b="0">
-                <a:solidFill>
-                  <a:srgbClr val="7D7767"/>
-                </a:solidFill>
-                <a:latin typeface="IBM Plex Mono"/>
+              <a:rPr sz="1100" b="1">
+                <a:solidFill>
+                  <a:srgbClr val="0B5D4B"/>
+                </a:solidFill>
+                <a:latin typeface="Arial"/>
               </a:rPr>
               <a:t>THE PROBLEM</a:t>
             </a:r>
@@ -3439,7 +3454,7 @@
         </p:nvSpPr>
         <p:spPr>
           <a:xfrm>
-            <a:off x="777240" y="960120"/>
+            <a:off x="777240" y="914400"/>
             <a:ext cx="10607040" cy="914400"/>
           </a:xfrm>
           <a:prstGeom prst="rect">
@@ -3459,11 +3474,11 @@
               </a:spcAft>
             </a:pPr>
             <a:r>
-              <a:rPr sz="3000" b="0">
-                <a:solidFill>
-                  <a:srgbClr val="17150F"/>
-                </a:solidFill>
-                <a:latin typeface="Newsreader"/>
+              <a:rPr sz="3200" b="0">
+                <a:solidFill>
+                  <a:srgbClr val="0E1412"/>
+                </a:solidFill>
+                <a:latin typeface="Georgia"/>
               </a:rPr>
               <a:t>Rejections are paperwork, not medicine</a:t>
             </a:r>
@@ -3486,7 +3501,7 @@
           </a:prstGeom>
           <a:ln w="9525">
             <a:solidFill>
-              <a:srgbClr val="E2DED2"/>
+              <a:srgbClr val="E1E3DD"/>
             </a:solidFill>
           </a:ln>
         </p:spPr>
@@ -3513,8 +3528,8 @@
         </p:nvSpPr>
         <p:spPr>
           <a:xfrm>
-            <a:off x="822960" y="2286000"/>
-            <a:ext cx="6949440" cy="3291840"/>
+            <a:off x="822960" y="2240280"/>
+            <a:ext cx="6949440" cy="3566160"/>
           </a:xfrm>
           <a:prstGeom prst="rect">
             <a:avLst/>
@@ -3535,11 +3550,11 @@
             <a:r>
               <a:rPr sz="1500">
                 <a:solidFill>
-                  <a:srgbClr val="4A463B"/>
-                </a:solidFill>
-                <a:latin typeface="IBM Plex Sans"/>
-              </a:rPr>
-              <a:t>A clinic treats an insured patient, then bills the insurer or TPA.</a:t>
+                  <a:srgbClr val="3E4945"/>
+                </a:solidFill>
+                <a:latin typeface="Arial"/>
+              </a:rPr>
+              <a:t>A clinic treats an insured patient, then bills the insurer or TPA. A large share of those claims come back rejected — for a missing pre-authorisation, a filing deadline passed, documents left out.</a:t>
             </a:r>
           </a:p>
           <a:p>
@@ -3548,85 +3563,21 @@
                 <a:spcPts val="300"/>
               </a:spcAft>
             </a:pPr>
+          </a:p>
+          <a:p>
+            <a:pPr>
+              <a:spcAft>
+                <a:spcPts val="300"/>
+              </a:spcAft>
+            </a:pPr>
             <a:r>
               <a:rPr sz="1500">
                 <a:solidFill>
-                  <a:srgbClr val="4A463B"/>
-                </a:solidFill>
-                <a:latin typeface="IBM Plex Sans"/>
-              </a:rPr>
-              <a:t>A large share of those claims come back rejected — for missing</a:t>
-            </a:r>
-          </a:p>
-          <a:p>
-            <a:pPr>
-              <a:spcAft>
-                <a:spcPts val="300"/>
-              </a:spcAft>
-            </a:pPr>
-            <a:r>
-              <a:rPr sz="1500">
-                <a:solidFill>
-                  <a:srgbClr val="4A463B"/>
-                </a:solidFill>
-                <a:latin typeface="IBM Plex Sans"/>
-              </a:rPr>
-              <a:t>pre-authorisation, a filing deadline passed, documents left out.</a:t>
-            </a:r>
-          </a:p>
-          <a:p>
-            <a:pPr>
-              <a:spcAft>
-                <a:spcPts val="300"/>
-              </a:spcAft>
-            </a:pPr>
-          </a:p>
-          <a:p>
-            <a:pPr>
-              <a:spcAft>
-                <a:spcPts val="300"/>
-              </a:spcAft>
-            </a:pPr>
-            <a:r>
-              <a:rPr sz="1500">
-                <a:solidFill>
-                  <a:srgbClr val="4A463B"/>
-                </a:solidFill>
-                <a:latin typeface="IBM Plex Sans"/>
-              </a:rPr>
-              <a:t>The clinic finds out weeks later. Small clinics have no billing</a:t>
-            </a:r>
-          </a:p>
-          <a:p>
-            <a:pPr>
-              <a:spcAft>
-                <a:spcPts val="300"/>
-              </a:spcAft>
-            </a:pPr>
-            <a:r>
-              <a:rPr sz="1500">
-                <a:solidFill>
-                  <a:srgbClr val="4A463B"/>
-                </a:solidFill>
-                <a:latin typeface="IBM Plex Sans"/>
-              </a:rPr>
-              <a:t>specialist to catch it. Cash flow becomes unpredictable, and clinics</a:t>
-            </a:r>
-          </a:p>
-          <a:p>
-            <a:pPr>
-              <a:spcAft>
-                <a:spcPts val="300"/>
-              </a:spcAft>
-            </a:pPr>
-            <a:r>
-              <a:rPr sz="1500">
-                <a:solidFill>
-                  <a:srgbClr val="4A463B"/>
-                </a:solidFill>
-                <a:latin typeface="IBM Plex Sans"/>
-              </a:rPr>
-              <a:t>eventually stop accepting insurance patients at all.</a:t>
+                  <a:srgbClr val="3E4945"/>
+                </a:solidFill>
+                <a:latin typeface="Arial"/>
+              </a:rPr>
+              <a:t>The clinic finds out weeks later. Small clinics have no billing specialist to catch it. Cash flow becomes unpredictable, and clinics eventually stop accepting insurance patients at all.</a:t>
             </a:r>
           </a:p>
         </p:txBody>
@@ -3639,7 +3590,7 @@
         </p:nvSpPr>
         <p:spPr>
           <a:xfrm>
-            <a:off x="822960" y="6035040"/>
+            <a:off x="822960" y="6080760"/>
             <a:ext cx="10515600" cy="365760"/>
           </a:xfrm>
           <a:prstGeom prst="rect">
@@ -3661,11 +3612,11 @@
             <a:r>
               <a:rPr sz="1100" b="0">
                 <a:solidFill>
-                  <a:srgbClr val="7D7767"/>
-                </a:solidFill>
-                <a:latin typeface="IBM Plex Mono"/>
-              </a:rPr>
-              <a:t>A financial inclusion problem as much as a healthcare one</a:t>
+                  <a:srgbClr val="5F6A66"/>
+                </a:solidFill>
+                <a:latin typeface="Arial"/>
+              </a:rPr>
+              <a:t>A financial-inclusion problem as much as a healthcare one</a:t>
             </a:r>
           </a:p>
         </p:txBody>
@@ -3678,7 +3629,7 @@
         </p:nvSpPr>
         <p:spPr>
           <a:xfrm>
-            <a:off x="11247120" y="6035040"/>
+            <a:off x="11247120" y="6080760"/>
             <a:ext cx="548640" cy="365760"/>
           </a:xfrm>
           <a:prstGeom prst="rect">
@@ -3700,9 +3651,9 @@
             <a:r>
               <a:rPr sz="1100" b="0">
                 <a:solidFill>
-                  <a:srgbClr val="7D7767"/>
-                </a:solidFill>
-                <a:latin typeface="IBM Plex Mono"/>
+                  <a:srgbClr val="5F6A66"/>
+                </a:solidFill>
+                <a:latin typeface="Arial"/>
               </a:rPr>
               <a:t>2</a:t>
             </a:r>
@@ -3723,7 +3674,7 @@
     <p:bg>
       <p:bgPr>
         <a:solidFill>
-          <a:srgbClr val="FAF9F6"/>
+          <a:srgbClr val="F6F6F3"/>
         </a:solidFill>
         <a:effectLst/>
       </p:bgPr>
@@ -3763,13 +3714,13 @@
               </a:spcAft>
             </a:pPr>
             <a:r>
-              <a:rPr sz="1100" b="0">
-                <a:solidFill>
-                  <a:srgbClr val="7D7767"/>
-                </a:solidFill>
-                <a:latin typeface="IBM Plex Mono"/>
-              </a:rPr>
-              <a:t>WHAT IT DOES</a:t>
+              <a:rPr sz="1100" b="1">
+                <a:solidFill>
+                  <a:srgbClr val="0B5D4B"/>
+                </a:solidFill>
+                <a:latin typeface="Arial"/>
+              </a:rPr>
+              <a:t>HOW IT WORKS</a:t>
             </a:r>
           </a:p>
         </p:txBody>
@@ -3782,7 +3733,7 @@
         </p:nvSpPr>
         <p:spPr>
           <a:xfrm>
-            <a:off x="777240" y="960120"/>
+            <a:off x="777240" y="914400"/>
             <a:ext cx="10607040" cy="914400"/>
           </a:xfrm>
           <a:prstGeom prst="rect">
@@ -3802,13 +3753,13 @@
               </a:spcAft>
             </a:pPr>
             <a:r>
-              <a:rPr sz="3000" b="0">
-                <a:solidFill>
-                  <a:srgbClr val="17150F"/>
-                </a:solidFill>
-                <a:latin typeface="Newsreader"/>
-              </a:rPr>
-              <a:t>Three parts, none of them mocked</a:t>
+              <a:rPr sz="3200" b="0">
+                <a:solidFill>
+                  <a:srgbClr val="0E1412"/>
+                </a:solidFill>
+                <a:latin typeface="Georgia"/>
+              </a:rPr>
+              <a:t>Enter the bill. Answer what matters.</a:t>
             </a:r>
           </a:p>
         </p:txBody>
@@ -3829,7 +3780,7 @@
           </a:prstGeom>
           <a:ln w="9525">
             <a:solidFill>
-              <a:srgbClr val="E2DED2"/>
+              <a:srgbClr val="E1E3DD"/>
             </a:solidFill>
           </a:ln>
         </p:spPr>
@@ -3856,8 +3807,8 @@
         </p:nvSpPr>
         <p:spPr>
           <a:xfrm>
-            <a:off x="822960" y="2286000"/>
-            <a:ext cx="6949440" cy="3291840"/>
+            <a:off x="822960" y="2240280"/>
+            <a:ext cx="5120640" cy="3566160"/>
           </a:xfrm>
           <a:prstGeom prst="rect">
             <a:avLst/>
@@ -3876,13 +3827,13 @@
               </a:spcAft>
             </a:pPr>
             <a:r>
-              <a:rPr sz="1500">
-                <a:solidFill>
-                  <a:srgbClr val="4A463B"/>
-                </a:solidFill>
-                <a:latin typeface="IBM Plex Sans"/>
-              </a:rPr>
-              <a:t>1.  Risk model — LightGBM gives a calibrated probability; SHAP names</a:t>
+              <a:rPr sz="1400">
+                <a:solidFill>
+                  <a:srgbClr val="3E4945"/>
+                </a:solidFill>
+                <a:latin typeface="Arial"/>
+              </a:rPr>
+              <a:t>1.  The clerk enters the patient and the bill: procedure and amount.</a:t>
             </a:r>
           </a:p>
           <a:p>
@@ -3892,13 +3843,13 @@
               </a:spcAft>
             </a:pPr>
             <a:r>
-              <a:rPr sz="1500">
-                <a:solidFill>
-                  <a:srgbClr val="4A463B"/>
-                </a:solidFill>
-                <a:latin typeface="IBM Plex Sans"/>
-              </a:rPr>
-              <a:t>     the specific field driving it; a second model predicts the real</a:t>
+              <a:rPr sz="1400">
+                <a:solidFill>
+                  <a:srgbClr val="3E4945"/>
+                </a:solidFill>
+                <a:latin typeface="Arial"/>
+              </a:rPr>
+              <a:t>2.  The tool asks only the paperwork questions that matter for this claim, choosing each by expected information gain.</a:t>
             </a:r>
           </a:p>
           <a:p>
@@ -3908,13 +3859,13 @@
               </a:spcAft>
             </a:pPr>
             <a:r>
-              <a:rPr sz="1500">
-                <a:solidFill>
-                  <a:srgbClr val="4A463B"/>
-                </a:solidFill>
-                <a:latin typeface="IBM Plex Sans"/>
-              </a:rPr>
-              <a:t>     X12 CARC reason code.</a:t>
+              <a:rPr sz="1400">
+                <a:solidFill>
+                  <a:srgbClr val="3E4945"/>
+                </a:solidFill>
+                <a:latin typeface="Arial"/>
+              </a:rPr>
+              <a:t>3.  It returns the risk, the fields driving it, the likely X12 CARC reason code, and the one thing to do before submitting.</a:t>
             </a:r>
           </a:p>
           <a:p>
@@ -3931,98 +3882,51 @@
               </a:spcAft>
             </a:pPr>
             <a:r>
-              <a:rPr sz="1500">
-                <a:solidFill>
-                  <a:srgbClr val="4A463B"/>
-                </a:solidFill>
-                <a:latin typeface="IBM Plex Sans"/>
-              </a:rPr>
-              <a:t>2.  Adaptive questioning — after every answer it computes the mutual</a:t>
-            </a:r>
-          </a:p>
-          <a:p>
-            <a:pPr>
-              <a:spcAft>
-                <a:spcPts val="300"/>
-              </a:spcAft>
-            </a:pPr>
-            <a:r>
-              <a:rPr sz="1500">
-                <a:solidFill>
-                  <a:srgbClr val="4A463B"/>
-                </a:solidFill>
-                <a:latin typeface="IBM Plex Sans"/>
-              </a:rPr>
-              <a:t>     information between the outcome and each unanswered field, then</a:t>
-            </a:r>
-          </a:p>
-          <a:p>
-            <a:pPr>
-              <a:spcAft>
-                <a:spcPts val="300"/>
-              </a:spcAft>
-            </a:pPr>
-            <a:r>
-              <a:rPr sz="1500">
-                <a:solidFill>
-                  <a:srgbClr val="4A463B"/>
-                </a:solidFill>
-                <a:latin typeface="IBM Plex Sans"/>
-              </a:rPr>
-              <a:t>     asks whichever would reduce uncertainty most.</a:t>
-            </a:r>
-          </a:p>
-          <a:p>
-            <a:pPr>
-              <a:spcAft>
-                <a:spcPts val="300"/>
-              </a:spcAft>
-            </a:pPr>
-          </a:p>
-          <a:p>
-            <a:pPr>
-              <a:spcAft>
-                <a:spcPts val="300"/>
-              </a:spcAft>
-            </a:pPr>
-            <a:r>
-              <a:rPr sz="1500">
-                <a:solidFill>
-                  <a:srgbClr val="4A463B"/>
-                </a:solidFill>
-                <a:latin typeface="IBM Plex Sans"/>
-              </a:rPr>
-              <a:t>3.  Plain language — Qwen restates the computed result in two</a:t>
-            </a:r>
-          </a:p>
-          <a:p>
-            <a:pPr>
-              <a:spcAft>
-                <a:spcPts val="300"/>
-              </a:spcAft>
-            </a:pPr>
-            <a:r>
-              <a:rPr sz="1500">
-                <a:solidFill>
-                  <a:srgbClr val="4A463B"/>
-                </a:solidFill>
-                <a:latin typeface="IBM Plex Sans"/>
-              </a:rPr>
-              <a:t>     sentences. It cannot change the number, the code, or the fields.</a:t>
-            </a:r>
-          </a:p>
-        </p:txBody>
-      </p:sp>
-      <p:sp>
-        <p:nvSpPr>
-          <p:cNvPr id="6" name="TextBox 5"/>
+              <a:rPr sz="1400">
+                <a:solidFill>
+                  <a:srgbClr val="3E4945"/>
+                </a:solidFill>
+                <a:latin typeface="Arial"/>
+              </a:rPr>
+              <a:t>When the procedure needs pre-authorisation, that is always the first question — a claim that needed it is never cleared without it.</a:t>
+            </a:r>
+          </a:p>
+        </p:txBody>
+      </p:sp>
+      <p:pic>
+        <p:nvPicPr>
+          <p:cNvPr id="6" name="Picture 5" descr="check.png"/>
+          <p:cNvPicPr>
+            <a:picLocks noChangeAspect="1"/>
+          </p:cNvPicPr>
+          <p:nvPr/>
+        </p:nvPicPr>
+        <p:blipFill>
+          <a:blip r:embed="rId2"/>
+          <a:stretch>
+            <a:fillRect/>
+          </a:stretch>
+        </p:blipFill>
+        <p:spPr>
+          <a:xfrm>
+            <a:off x="6263640" y="2240280"/>
+            <a:ext cx="5120640" cy="3200400"/>
+          </a:xfrm>
+          <a:prstGeom prst="rect">
+            <a:avLst/>
+          </a:prstGeom>
+        </p:spPr>
+      </p:pic>
+      <p:sp>
+        <p:nvSpPr>
+          <p:cNvPr id="7" name="TextBox 6"/>
           <p:cNvSpPr txBox="1"/>
           <p:nvPr/>
         </p:nvSpPr>
         <p:spPr>
           <a:xfrm>
-            <a:off x="11247120" y="6035040"/>
-            <a:ext cx="548640" cy="365760"/>
+            <a:off x="822960" y="6080760"/>
+            <a:ext cx="10515600" cy="365760"/>
           </a:xfrm>
           <a:prstGeom prst="rect">
             <a:avLst/>
@@ -4043,9 +3947,48 @@
             <a:r>
               <a:rPr sz="1100" b="0">
                 <a:solidFill>
-                  <a:srgbClr val="7D7767"/>
-                </a:solidFill>
-                <a:latin typeface="IBM Plex Mono"/>
+                  <a:srgbClr val="5F6A66"/>
+                </a:solidFill>
+                <a:latin typeface="Arial"/>
+              </a:rPr>
+              <a:t>Calibrated LightGBM · exact Shapley attribution · Qwen on Alibaba Cloud DashScope</a:t>
+            </a:r>
+          </a:p>
+        </p:txBody>
+      </p:sp>
+      <p:sp>
+        <p:nvSpPr>
+          <p:cNvPr id="8" name="TextBox 7"/>
+          <p:cNvSpPr txBox="1"/>
+          <p:nvPr/>
+        </p:nvSpPr>
+        <p:spPr>
+          <a:xfrm>
+            <a:off x="11247120" y="6080760"/>
+            <a:ext cx="548640" cy="365760"/>
+          </a:xfrm>
+          <a:prstGeom prst="rect">
+            <a:avLst/>
+          </a:prstGeom>
+          <a:noFill/>
+        </p:spPr>
+        <p:txBody>
+          <a:bodyPr wrap="none">
+            <a:spAutoFit/>
+          </a:bodyPr>
+          <a:lstStyle/>
+          <a:p>
+            <a:pPr algn="l">
+              <a:spcAft>
+                <a:spcPts val="0"/>
+              </a:spcAft>
+            </a:pPr>
+            <a:r>
+              <a:rPr sz="1100" b="0">
+                <a:solidFill>
+                  <a:srgbClr val="5F6A66"/>
+                </a:solidFill>
+                <a:latin typeface="Arial"/>
               </a:rPr>
               <a:t>3</a:t>
             </a:r>
@@ -4066,7 +4009,7 @@
     <p:bg>
       <p:bgPr>
         <a:solidFill>
-          <a:srgbClr val="FAF9F6"/>
+          <a:srgbClr val="F6F6F3"/>
         </a:solidFill>
         <a:effectLst/>
       </p:bgPr>
@@ -4106,11 +4049,11 @@
               </a:spcAft>
             </a:pPr>
             <a:r>
-              <a:rPr sz="1100" b="0">
-                <a:solidFill>
-                  <a:srgbClr val="7D7767"/>
-                </a:solidFill>
-                <a:latin typeface="IBM Plex Mono"/>
+              <a:rPr sz="1100" b="1">
+                <a:solidFill>
+                  <a:srgbClr val="0B5D4B"/>
+                </a:solidFill>
+                <a:latin typeface="Arial"/>
               </a:rPr>
               <a:t>THE DIFFERENTIATOR</a:t>
             </a:r>
@@ -4125,7 +4068,7 @@
         </p:nvSpPr>
         <p:spPr>
           <a:xfrm>
-            <a:off x="777240" y="960120"/>
+            <a:off x="777240" y="914400"/>
             <a:ext cx="10607040" cy="914400"/>
           </a:xfrm>
           <a:prstGeom prst="rect">
@@ -4145,11 +4088,11 @@
               </a:spcAft>
             </a:pPr>
             <a:r>
-              <a:rPr sz="3000" b="0">
-                <a:solidFill>
-                  <a:srgbClr val="17150F"/>
-                </a:solidFill>
-                <a:latin typeface="Newsreader"/>
+              <a:rPr sz="3200" b="0">
+                <a:solidFill>
+                  <a:srgbClr val="0E1412"/>
+                </a:solidFill>
+                <a:latin typeface="Georgia"/>
               </a:rPr>
               <a:t>It asks, it doesn't just collect</a:t>
             </a:r>
@@ -4172,7 +4115,7 @@
           </a:prstGeom>
           <a:ln w="9525">
             <a:solidFill>
-              <a:srgbClr val="E2DED2"/>
+              <a:srgbClr val="E1E3DD"/>
             </a:solidFill>
           </a:ln>
         </p:spPr>
@@ -4199,8 +4142,8 @@
         </p:nvSpPr>
         <p:spPr>
           <a:xfrm>
-            <a:off x="822960" y="2286000"/>
-            <a:ext cx="6949440" cy="3291840"/>
+            <a:off x="822960" y="2240280"/>
+            <a:ext cx="6949440" cy="3566160"/>
           </a:xfrm>
           <a:prstGeom prst="rect">
             <a:avLst/>
@@ -4221,11 +4164,11 @@
             <a:r>
               <a:rPr sz="1500">
                 <a:solidFill>
-                  <a:srgbClr val="4A463B"/>
-                </a:solidFill>
-                <a:latin typeface="IBM Plex Sans"/>
-              </a:rPr>
-              <a:t>Most tools in this space are a form with a model bolted on.</a:t>
+                  <a:srgbClr val="3E4945"/>
+                </a:solidFill>
+                <a:latin typeface="Arial"/>
+              </a:rPr>
+              <a:t>Most tools here are a form with a model bolted on, or a fixed decision tree. This one computes, after every answer, how much each remaining question would reduce its uncertainty about this claim, and asks that one.</a:t>
             </a:r>
           </a:p>
           <a:p>
@@ -4234,76 +4177,21 @@
                 <a:spcPts val="300"/>
               </a:spcAft>
             </a:pPr>
+          </a:p>
+          <a:p>
+            <a:pPr>
+              <a:spcAft>
+                <a:spcPts val="300"/>
+              </a:spcAft>
+            </a:pPr>
             <a:r>
               <a:rPr sz="1500">
                 <a:solidFill>
-                  <a:srgbClr val="4A463B"/>
-                </a:solidFill>
-                <a:latin typeface="IBM Plex Sans"/>
-              </a:rPr>
-              <a:t>Insurance chatbots that do adaptive intake run a decision tree.</a:t>
-            </a:r>
-          </a:p>
-          <a:p>
-            <a:pPr>
-              <a:spcAft>
-                <a:spcPts val="300"/>
-              </a:spcAft>
-            </a:pPr>
-          </a:p>
-          <a:p>
-            <a:pPr>
-              <a:spcAft>
-                <a:spcPts val="300"/>
-              </a:spcAft>
-            </a:pPr>
-            <a:r>
-              <a:rPr sz="1500">
-                <a:solidFill>
-                  <a:srgbClr val="4A463B"/>
-                </a:solidFill>
-                <a:latin typeface="IBM Plex Sans"/>
-              </a:rPr>
-              <a:t>Ours is information-theoretic: the next question is the one with the</a:t>
-            </a:r>
-          </a:p>
-          <a:p>
-            <a:pPr>
-              <a:spcAft>
-                <a:spcPts val="300"/>
-              </a:spcAft>
-            </a:pPr>
-            <a:r>
-              <a:rPr sz="1500">
-                <a:solidFill>
-                  <a:srgbClr val="4A463B"/>
-                </a:solidFill>
-                <a:latin typeface="IBM Plex Sans"/>
-              </a:rPr>
-              <a:t>highest mutual information with the outcome, given what is known.</a:t>
-            </a:r>
-          </a:p>
-          <a:p>
-            <a:pPr>
-              <a:spcAft>
-                <a:spcPts val="300"/>
-              </a:spcAft>
-            </a:pPr>
-          </a:p>
-          <a:p>
-            <a:pPr>
-              <a:spcAft>
-                <a:spcPts val="300"/>
-              </a:spcAft>
-            </a:pPr>
-            <a:r>
-              <a:rPr sz="1500">
-                <a:solidFill>
-                  <a:srgbClr val="4A463B"/>
-                </a:solidFill>
-                <a:latin typeface="IBM Plex Sans"/>
-              </a:rPr>
-              <a:t>Across 200 held-out claims we see 72 distinct question orders.</a:t>
+                  <a:srgbClr val="3E4945"/>
+                </a:solidFill>
+                <a:latin typeface="Arial"/>
+              </a:rPr>
+              <a:t>It stops as soon as the verdict is settled: never before 3 questions, never after 8.</a:t>
             </a:r>
           </a:p>
         </p:txBody>
@@ -4316,7 +4204,7 @@
         </p:nvSpPr>
         <p:spPr>
           <a:xfrm>
-            <a:off x="8229600" y="2377440"/>
+            <a:off x="8229600" y="2286000"/>
             <a:ext cx="3108960" cy="640080"/>
           </a:xfrm>
           <a:prstGeom prst="rect">
@@ -4336,13 +4224,13 @@
               </a:spcAft>
             </a:pPr>
             <a:r>
-              <a:rPr sz="3400" b="0">
-                <a:solidFill>
-                  <a:srgbClr val="1F4B43"/>
-                </a:solidFill>
-                <a:latin typeface="Newsreader"/>
-              </a:rPr>
-              <a:t>72</a:t>
+              <a:rPr sz="3400" b="1">
+                <a:solidFill>
+                  <a:srgbClr val="0B5D4B"/>
+                </a:solidFill>
+                <a:latin typeface="Arial"/>
+              </a:rPr>
+              <a:t>52</a:t>
             </a:r>
           </a:p>
         </p:txBody>
@@ -4355,7 +4243,7 @@
         </p:nvSpPr>
         <p:spPr>
           <a:xfrm>
-            <a:off x="8275320" y="2944368"/>
+            <a:off x="8275320" y="2852928"/>
             <a:ext cx="3108960" cy="365760"/>
           </a:xfrm>
           <a:prstGeom prst="rect">
@@ -4377,11 +4265,11 @@
             <a:r>
               <a:rPr sz="1100" b="0">
                 <a:solidFill>
-                  <a:srgbClr val="7D7767"/>
-                </a:solidFill>
-                <a:latin typeface="IBM Plex Mono"/>
-              </a:rPr>
-              <a:t>distinct question orders</a:t>
+                  <a:srgbClr val="5F6A66"/>
+                </a:solidFill>
+                <a:latin typeface="Arial"/>
+              </a:rPr>
+              <a:t>question orders across 362 test claims</a:t>
             </a:r>
           </a:p>
         </p:txBody>
@@ -4394,7 +4282,7 @@
         </p:nvSpPr>
         <p:spPr>
           <a:xfrm>
-            <a:off x="8229600" y="3611880"/>
+            <a:off x="8229600" y="3474720"/>
             <a:ext cx="3108960" cy="640080"/>
           </a:xfrm>
           <a:prstGeom prst="rect">
@@ -4414,13 +4302,13 @@
               </a:spcAft>
             </a:pPr>
             <a:r>
-              <a:rPr sz="3400" b="0">
-                <a:solidFill>
-                  <a:srgbClr val="1F4B43"/>
-                </a:solidFill>
-                <a:latin typeface="Newsreader"/>
-              </a:rPr>
-              <a:t>3.7</a:t>
+              <a:rPr sz="3400" b="1">
+                <a:solidFill>
+                  <a:srgbClr val="0B5D4B"/>
+                </a:solidFill>
+                <a:latin typeface="Arial"/>
+              </a:rPr>
+              <a:t>3.5</a:t>
             </a:r>
           </a:p>
         </p:txBody>
@@ -4433,7 +4321,7 @@
         </p:nvSpPr>
         <p:spPr>
           <a:xfrm>
-            <a:off x="8275320" y="4178808"/>
+            <a:off x="8275320" y="4041648"/>
             <a:ext cx="3108960" cy="365760"/>
           </a:xfrm>
           <a:prstGeom prst="rect">
@@ -4455,11 +4343,11 @@
             <a:r>
               <a:rPr sz="1100" b="0">
                 <a:solidFill>
-                  <a:srgbClr val="7D7767"/>
-                </a:solidFill>
-                <a:latin typeface="IBM Plex Mono"/>
-              </a:rPr>
-              <a:t>questions, clean claim</a:t>
+                  <a:srgbClr val="5F6A66"/>
+                </a:solidFill>
+                <a:latin typeface="Arial"/>
+              </a:rPr>
+              <a:t>questions on average</a:t>
             </a:r>
           </a:p>
         </p:txBody>
@@ -4472,7 +4360,7 @@
         </p:nvSpPr>
         <p:spPr>
           <a:xfrm>
-            <a:off x="8229600" y="4846320"/>
+            <a:off x="8229600" y="4663440"/>
             <a:ext cx="3108960" cy="640080"/>
           </a:xfrm>
           <a:prstGeom prst="rect">
@@ -4492,13 +4380,13 @@
               </a:spcAft>
             </a:pPr>
             <a:r>
-              <a:rPr sz="3400" b="0">
-                <a:solidFill>
-                  <a:srgbClr val="1F4B43"/>
-                </a:solidFill>
-                <a:latin typeface="Newsreader"/>
-              </a:rPr>
-              <a:t>4.1</a:t>
+              <a:rPr sz="3400" b="1">
+                <a:solidFill>
+                  <a:srgbClr val="0B5D4B"/>
+                </a:solidFill>
+                <a:latin typeface="Arial"/>
+              </a:rPr>
+              <a:t>6</a:t>
             </a:r>
           </a:p>
         </p:txBody>
@@ -4511,7 +4399,7 @@
         </p:nvSpPr>
         <p:spPr>
           <a:xfrm>
-            <a:off x="8275320" y="5413248"/>
+            <a:off x="8275320" y="5230368"/>
             <a:ext cx="3108960" cy="365760"/>
           </a:xfrm>
           <a:prstGeom prst="rect">
@@ -4533,11 +4421,11 @@
             <a:r>
               <a:rPr sz="1100" b="0">
                 <a:solidFill>
-                  <a:srgbClr val="7D7767"/>
-                </a:solidFill>
-                <a:latin typeface="IBM Plex Mono"/>
-              </a:rPr>
-              <a:t>questions, problem claim</a:t>
+                  <a:srgbClr val="5F6A66"/>
+                </a:solidFill>
+                <a:latin typeface="Arial"/>
+              </a:rPr>
+              <a:t>insurer rules checked on every claim</a:t>
             </a:r>
           </a:p>
         </p:txBody>
@@ -4550,7 +4438,7 @@
         </p:nvSpPr>
         <p:spPr>
           <a:xfrm>
-            <a:off x="11247120" y="6035040"/>
+            <a:off x="11247120" y="6080760"/>
             <a:ext cx="548640" cy="365760"/>
           </a:xfrm>
           <a:prstGeom prst="rect">
@@ -4572,9 +4460,9 @@
             <a:r>
               <a:rPr sz="1100" b="0">
                 <a:solidFill>
-                  <a:srgbClr val="7D7767"/>
-                </a:solidFill>
-                <a:latin typeface="IBM Plex Mono"/>
+                  <a:srgbClr val="5F6A66"/>
+                </a:solidFill>
+                <a:latin typeface="Arial"/>
               </a:rPr>
               <a:t>4</a:t>
             </a:r>
@@ -4595,7 +4483,7 @@
     <p:bg>
       <p:bgPr>
         <a:solidFill>
-          <a:srgbClr val="FAF9F6"/>
+          <a:srgbClr val="F6F6F3"/>
         </a:solidFill>
         <a:effectLst/>
       </p:bgPr>
@@ -4635,13 +4523,13 @@
               </a:spcAft>
             </a:pPr>
             <a:r>
-              <a:rPr sz="1100" b="0">
-                <a:solidFill>
-                  <a:srgbClr val="7D7767"/>
-                </a:solidFill>
-                <a:latin typeface="IBM Plex Mono"/>
-              </a:rPr>
-              <a:t>THE INTERFACE</a:t>
+              <a:rPr sz="1100" b="1">
+                <a:solidFill>
+                  <a:srgbClr val="0B5D4B"/>
+                </a:solidFill>
+                <a:latin typeface="Arial"/>
+              </a:rPr>
+              <a:t>THE VERDICT</a:t>
             </a:r>
           </a:p>
         </p:txBody>
@@ -4654,7 +4542,7 @@
         </p:nvSpPr>
         <p:spPr>
           <a:xfrm>
-            <a:off x="777240" y="960120"/>
+            <a:off x="777240" y="914400"/>
             <a:ext cx="10607040" cy="914400"/>
           </a:xfrm>
           <a:prstGeom prst="rect">
@@ -4674,13 +4562,13 @@
               </a:spcAft>
             </a:pPr>
             <a:r>
-              <a:rPr sz="3000" b="0">
-                <a:solidFill>
-                  <a:srgbClr val="17150F"/>
-                </a:solidFill>
-                <a:latin typeface="Newsreader"/>
-              </a:rPr>
-              <a:t>The estimate is never hidden</a:t>
+              <a:rPr sz="3200" b="0">
+                <a:solidFill>
+                  <a:srgbClr val="0E1412"/>
+                </a:solidFill>
+                <a:latin typeface="Georgia"/>
+              </a:rPr>
+              <a:t>Every number traces back</a:t>
             </a:r>
           </a:p>
         </p:txBody>
@@ -4701,7 +4589,7 @@
           </a:prstGeom>
           <a:ln w="9525">
             <a:solidFill>
-              <a:srgbClr val="E2DED2"/>
+              <a:srgbClr val="E1E3DD"/>
             </a:solidFill>
           </a:ln>
         </p:spPr>
@@ -4728,8 +4616,8 @@
         </p:nvSpPr>
         <p:spPr>
           <a:xfrm>
-            <a:off x="822960" y="2286000"/>
-            <a:ext cx="6949440" cy="3291840"/>
+            <a:off x="822960" y="2240280"/>
+            <a:ext cx="5120640" cy="3566160"/>
           </a:xfrm>
           <a:prstGeom prst="rect">
             <a:avLst/>
@@ -4748,13 +4636,13 @@
               </a:spcAft>
             </a:pPr>
             <a:r>
-              <a:rPr sz="1500">
-                <a:solidFill>
-                  <a:srgbClr val="4A463B"/>
-                </a:solidFill>
-                <a:latin typeface="IBM Plex Sans"/>
-              </a:rPr>
-              <a:t>The running probability is on screen from the first question, so there</a:t>
+              <a:rPr sz="1400">
+                <a:solidFill>
+                  <a:srgbClr val="3E4945"/>
+                </a:solidFill>
+                <a:latin typeface="Arial"/>
+              </a:rPr>
+              <a:t>The risk is a calibrated probability, with bands fitted by simulating the real question loop.</a:t>
             </a:r>
           </a:p>
           <a:p>
@@ -4763,15 +4651,6 @@
                 <a:spcPts val="300"/>
               </a:spcAft>
             </a:pPr>
-            <a:r>
-              <a:rPr sz="1500">
-                <a:solidFill>
-                  <a:srgbClr val="4A463B"/>
-                </a:solidFill>
-                <a:latin typeface="IBM Plex Sans"/>
-              </a:rPr>
-              <a:t>is no reveal to wait for. Every answer is scored against the reading</a:t>
-            </a:r>
           </a:p>
           <a:p>
             <a:pPr>
@@ -4780,13 +4659,13 @@
               </a:spcAft>
             </a:pPr>
             <a:r>
-              <a:rPr sz="1500">
-                <a:solidFill>
-                  <a:srgbClr val="4A463B"/>
-                </a:solidFill>
-                <a:latin typeface="IBM Plex Sans"/>
-              </a:rPr>
-              <a:t>immediately before it — a field that hurts the claim is flagged while</a:t>
+              <a:rPr sz="1400">
+                <a:solidFill>
+                  <a:srgbClr val="3E4945"/>
+                </a:solidFill>
+                <a:latin typeface="Arial"/>
+              </a:rPr>
+              <a:t>Shapley attribution names the fields driving it, and the points add up exactly from a typical claim to this one.</a:t>
             </a:r>
           </a:p>
           <a:p>
@@ -4795,15 +4674,6 @@
                 <a:spcPts val="300"/>
               </a:spcAft>
             </a:pPr>
-            <a:r>
-              <a:rPr sz="1500">
-                <a:solidFill>
-                  <a:srgbClr val="4A463B"/>
-                </a:solidFill>
-                <a:latin typeface="IBM Plex Sans"/>
-              </a:rPr>
-              <a:t>staff can still correct it, not in the verdict when they cannot.</a:t>
-            </a:r>
           </a:p>
           <a:p>
             <a:pPr>
@@ -4811,6 +4681,15 @@
                 <a:spcPts val="300"/>
               </a:spcAft>
             </a:pPr>
+            <a:r>
+              <a:rPr sz="1400">
+                <a:solidFill>
+                  <a:srgbClr val="3E4945"/>
+                </a:solidFill>
+                <a:latin typeface="Arial"/>
+              </a:rPr>
+              <a:t>Rule checks say what the clerk may not know: whether pre-approval was needed, how much of the filing window is left.</a:t>
+            </a:r>
           </a:p>
           <a:p>
             <a:pPr>
@@ -4818,15 +4697,6 @@
                 <a:spcPts val="300"/>
               </a:spcAft>
             </a:pPr>
-            <a:r>
-              <a:rPr sz="1500">
-                <a:solidFill>
-                  <a:srgbClr val="4A463B"/>
-                </a:solidFill>
-                <a:latin typeface="IBM Plex Sans"/>
-              </a:rPr>
-              <a:t>     "Supporting documents: Some missing — this raised the</a:t>
-            </a:r>
           </a:p>
           <a:p>
             <a:pPr>
@@ -4835,98 +4705,51 @@
               </a:spcAft>
             </a:pPr>
             <a:r>
-              <a:rPr sz="1500">
-                <a:solidFill>
-                  <a:srgbClr val="4A463B"/>
-                </a:solidFill>
-                <a:latin typeface="IBM Plex Sans"/>
-              </a:rPr>
-              <a:t>      estimate by 17 points."</a:t>
-            </a:r>
-          </a:p>
-          <a:p>
-            <a:pPr>
-              <a:spcAft>
-                <a:spcPts val="300"/>
-              </a:spcAft>
-            </a:pPr>
-          </a:p>
-          <a:p>
-            <a:pPr>
-              <a:spcAft>
-                <a:spcPts val="300"/>
-              </a:spcAft>
-            </a:pPr>
-            <a:r>
-              <a:rPr sz="1500">
-                <a:solidFill>
-                  <a:srgbClr val="4A463B"/>
-                </a:solidFill>
-                <a:latin typeface="IBM Plex Sans"/>
-              </a:rPr>
-              <a:t>SHAP attribution, the CARC citation and Qwen's plain-language reading</a:t>
-            </a:r>
-          </a:p>
-          <a:p>
-            <a:pPr>
-              <a:spcAft>
-                <a:spcPts val="300"/>
-              </a:spcAft>
-            </a:pPr>
-            <a:r>
-              <a:rPr sz="1500">
-                <a:solidFill>
-                  <a:srgbClr val="4A463B"/>
-                </a:solidFill>
-                <a:latin typeface="IBM Plex Sans"/>
-              </a:rPr>
-              <a:t>sit alongside it. No rejection reason is shown for a clean claim: the</a:t>
-            </a:r>
-          </a:p>
-          <a:p>
-            <a:pPr>
-              <a:spcAft>
-                <a:spcPts val="300"/>
-              </a:spcAft>
-            </a:pPr>
-            <a:r>
-              <a:rPr sz="1500">
-                <a:solidFill>
-                  <a:srgbClr val="4A463B"/>
-                </a:solidFill>
-                <a:latin typeface="IBM Plex Sans"/>
-              </a:rPr>
-              <a:t>reason model trains only on rejected claims, so naming one would be</a:t>
-            </a:r>
-          </a:p>
-          <a:p>
-            <a:pPr>
-              <a:spcAft>
-                <a:spcPts val="300"/>
-              </a:spcAft>
-            </a:pPr>
-            <a:r>
-              <a:rPr sz="1500">
-                <a:solidFill>
-                  <a:srgbClr val="4A463B"/>
-                </a:solidFill>
-                <a:latin typeface="IBM Plex Sans"/>
-              </a:rPr>
-              <a:t>inventing a problem.</a:t>
-            </a:r>
-          </a:p>
-        </p:txBody>
-      </p:sp>
-      <p:sp>
-        <p:nvSpPr>
-          <p:cNvPr id="6" name="TextBox 5"/>
+              <a:rPr sz="1400">
+                <a:solidFill>
+                  <a:srgbClr val="3E4945"/>
+                </a:solidFill>
+                <a:latin typeface="Arial"/>
+              </a:rPr>
+              <a:t>Qwen only words the result. Any reply with a number it was not given is rejected and replaced by a template.</a:t>
+            </a:r>
+          </a:p>
+        </p:txBody>
+      </p:sp>
+      <p:pic>
+        <p:nvPicPr>
+          <p:cNvPr id="6" name="Picture 5" descr="result-risky.png"/>
+          <p:cNvPicPr>
+            <a:picLocks noChangeAspect="1"/>
+          </p:cNvPicPr>
+          <p:nvPr/>
+        </p:nvPicPr>
+        <p:blipFill>
+          <a:blip r:embed="rId2"/>
+          <a:stretch>
+            <a:fillRect/>
+          </a:stretch>
+        </p:blipFill>
+        <p:spPr>
+          <a:xfrm>
+            <a:off x="6263640" y="2240280"/>
+            <a:ext cx="5120640" cy="3200400"/>
+          </a:xfrm>
+          <a:prstGeom prst="rect">
+            <a:avLst/>
+          </a:prstGeom>
+        </p:spPr>
+      </p:pic>
+      <p:sp>
+        <p:nvSpPr>
+          <p:cNvPr id="7" name="TextBox 6"/>
           <p:cNvSpPr txBox="1"/>
           <p:nvPr/>
         </p:nvSpPr>
         <p:spPr>
           <a:xfrm>
-            <a:off x="822960" y="6035040"/>
-            <a:ext cx="10515600" cy="365760"/>
+            <a:off x="11247120" y="6080760"/>
+            <a:ext cx="548640" cy="365760"/>
           </a:xfrm>
           <a:prstGeom prst="rect">
             <a:avLst/>
@@ -4947,48 +4770,9 @@
             <a:r>
               <a:rPr sz="1100" b="0">
                 <a:solidFill>
-                  <a:srgbClr val="7D7767"/>
-                </a:solidFill>
-                <a:latin typeface="IBM Plex Mono"/>
-              </a:rPr>
-              <a:t>Built for clinic admin staff — CARC, SHAP and information gain each carry a definition</a:t>
-            </a:r>
-          </a:p>
-        </p:txBody>
-      </p:sp>
-      <p:sp>
-        <p:nvSpPr>
-          <p:cNvPr id="7" name="TextBox 6"/>
-          <p:cNvSpPr txBox="1"/>
-          <p:nvPr/>
-        </p:nvSpPr>
-        <p:spPr>
-          <a:xfrm>
-            <a:off x="11247120" y="6035040"/>
-            <a:ext cx="548640" cy="365760"/>
-          </a:xfrm>
-          <a:prstGeom prst="rect">
-            <a:avLst/>
-          </a:prstGeom>
-          <a:noFill/>
-        </p:spPr>
-        <p:txBody>
-          <a:bodyPr wrap="none">
-            <a:spAutoFit/>
-          </a:bodyPr>
-          <a:lstStyle/>
-          <a:p>
-            <a:pPr algn="l">
-              <a:spcAft>
-                <a:spcPts val="0"/>
-              </a:spcAft>
-            </a:pPr>
-            <a:r>
-              <a:rPr sz="1100" b="0">
-                <a:solidFill>
-                  <a:srgbClr val="7D7767"/>
-                </a:solidFill>
-                <a:latin typeface="IBM Plex Mono"/>
+                  <a:srgbClr val="5F6A66"/>
+                </a:solidFill>
+                <a:latin typeface="Arial"/>
               </a:rPr>
               <a:t>5</a:t>
             </a:r>
@@ -5009,7 +4793,7 @@
     <p:bg>
       <p:bgPr>
         <a:solidFill>
-          <a:srgbClr val="FAF9F6"/>
+          <a:srgbClr val="F6F6F3"/>
         </a:solidFill>
         <a:effectLst/>
       </p:bgPr>
@@ -5049,11 +4833,11 @@
               </a:spcAft>
             </a:pPr>
             <a:r>
-              <a:rPr sz="1100" b="0">
-                <a:solidFill>
-                  <a:srgbClr val="7D7767"/>
-                </a:solidFill>
-                <a:latin typeface="IBM Plex Mono"/>
+              <a:rPr sz="1100" b="1">
+                <a:solidFill>
+                  <a:srgbClr val="0B5D4B"/>
+                </a:solidFill>
+                <a:latin typeface="Arial"/>
               </a:rPr>
               <a:t>RESULTS</a:t>
             </a:r>
@@ -5068,7 +4852,7 @@
         </p:nvSpPr>
         <p:spPr>
           <a:xfrm>
-            <a:off x="777240" y="960120"/>
+            <a:off x="777240" y="914400"/>
             <a:ext cx="10607040" cy="914400"/>
           </a:xfrm>
           <a:prstGeom prst="rect">
@@ -5088,13 +4872,13 @@
               </a:spcAft>
             </a:pPr>
             <a:r>
-              <a:rPr sz="3000" b="0">
-                <a:solidFill>
-                  <a:srgbClr val="17150F"/>
-                </a:solidFill>
-                <a:latin typeface="Newsreader"/>
-              </a:rPr>
-              <a:t>Deliberately not perfect</a:t>
+              <a:rPr sz="3200" b="0">
+                <a:solidFill>
+                  <a:srgbClr val="0E1412"/>
+                </a:solidFill>
+                <a:latin typeface="Georgia"/>
+              </a:rPr>
+              <a:t>On claims the model never saw</a:t>
             </a:r>
           </a:p>
         </p:txBody>
@@ -5115,7 +4899,7 @@
           </a:prstGeom>
           <a:ln w="9525">
             <a:solidFill>
-              <a:srgbClr val="E2DED2"/>
+              <a:srgbClr val="E1E3DD"/>
             </a:solidFill>
           </a:ln>
         </p:spPr>
@@ -5142,8 +4926,8 @@
         </p:nvSpPr>
         <p:spPr>
           <a:xfrm>
-            <a:off x="822960" y="2286000"/>
-            <a:ext cx="6949440" cy="3291840"/>
+            <a:off x="822960" y="2240280"/>
+            <a:ext cx="6949440" cy="3566160"/>
           </a:xfrm>
           <a:prstGeom prst="rect">
             <a:avLst/>
@@ -5164,11 +4948,11 @@
             <a:r>
               <a:rPr sz="1500">
                 <a:solidFill>
-                  <a:srgbClr val="4A463B"/>
-                </a:solidFill>
-                <a:latin typeface="IBM Plex Sans"/>
-              </a:rPr>
-              <a:t>Only 26.5% of claims are rejected, so blindly approving everything</a:t>
+                  <a:srgbClr val="3E4945"/>
+                </a:solidFill>
+                <a:latin typeface="Arial"/>
+              </a:rPr>
+              <a:t>Only 24% of claims are rejected, so blindly approving everything already scores 76%. AUC and verdict quality are the honest headline.</a:t>
             </a:r>
           </a:p>
           <a:p>
@@ -5177,69 +4961,21 @@
                 <a:spcPts val="300"/>
               </a:spcAft>
             </a:pPr>
+          </a:p>
+          <a:p>
+            <a:pPr>
+              <a:spcAft>
+                <a:spcPts val="300"/>
+              </a:spcAft>
+            </a:pPr>
             <a:r>
               <a:rPr sz="1500">
                 <a:solidFill>
-                  <a:srgbClr val="4A463B"/>
-                </a:solidFill>
-                <a:latin typeface="IBM Plex Sans"/>
-              </a:rPr>
-              <a:t>already scores 73.5%. Accuracy is the wrong headline — AUC and recall</a:t>
-            </a:r>
-          </a:p>
-          <a:p>
-            <a:pPr>
-              <a:spcAft>
-                <a:spcPts val="300"/>
-              </a:spcAft>
-            </a:pPr>
-            <a:r>
-              <a:rPr sz="1500">
-                <a:solidFill>
-                  <a:srgbClr val="4A463B"/>
-                </a:solidFill>
-                <a:latin typeface="IBM Plex Sans"/>
-              </a:rPr>
-              <a:t>are the meaningful numbers.</a:t>
-            </a:r>
-          </a:p>
-          <a:p>
-            <a:pPr>
-              <a:spcAft>
-                <a:spcPts val="300"/>
-              </a:spcAft>
-            </a:pPr>
-          </a:p>
-          <a:p>
-            <a:pPr>
-              <a:spcAft>
-                <a:spcPts val="300"/>
-              </a:spcAft>
-            </a:pPr>
-            <a:r>
-              <a:rPr sz="1500">
-                <a:solidFill>
-                  <a:srgbClr val="4A463B"/>
-                </a:solidFill>
-                <a:latin typeface="IBM Plex Sans"/>
-              </a:rPr>
-              <a:t>Per-code accuracy is highest where it matters: 92% on CARC 197,</a:t>
-            </a:r>
-          </a:p>
-          <a:p>
-            <a:pPr>
-              <a:spcAft>
-                <a:spcPts val="300"/>
-              </a:spcAft>
-            </a:pPr>
-            <a:r>
-              <a:rPr sz="1500">
-                <a:solidFill>
-                  <a:srgbClr val="4A463B"/>
-                </a:solidFill>
-                <a:latin typeface="IBM Plex Sans"/>
-              </a:rPr>
-              <a:t>pre-authorisation absent.</a:t>
+                  <a:srgbClr val="3E4945"/>
+                </a:solidFill>
+                <a:latin typeface="Arial"/>
+              </a:rPr>
+              <a:t>Claims cleared as low risk: 62% of all, 89% of them accepted. Claims flagged high: 26% of all, 56% of them rejected. Accuracy at the high-risk line: 81.8%. Reason code: 88% top-1 across 12 real codes.</a:t>
             </a:r>
           </a:p>
         </p:txBody>
@@ -5252,7 +4988,7 @@
         </p:nvSpPr>
         <p:spPr>
           <a:xfrm>
-            <a:off x="8229600" y="2377440"/>
+            <a:off x="8229600" y="2286000"/>
             <a:ext cx="3108960" cy="640080"/>
           </a:xfrm>
           <a:prstGeom prst="rect">
@@ -5272,13 +5008,13 @@
               </a:spcAft>
             </a:pPr>
             <a:r>
-              <a:rPr sz="3400" b="0">
-                <a:solidFill>
-                  <a:srgbClr val="1F4B43"/>
-                </a:solidFill>
-                <a:latin typeface="Newsreader"/>
-              </a:rPr>
-              <a:t>0.788</a:t>
+              <a:rPr sz="3400" b="1">
+                <a:solidFill>
+                  <a:srgbClr val="0B5D4B"/>
+                </a:solidFill>
+                <a:latin typeface="Arial"/>
+              </a:rPr>
+              <a:t>0.85</a:t>
             </a:r>
           </a:p>
         </p:txBody>
@@ -5291,7 +5027,7 @@
         </p:nvSpPr>
         <p:spPr>
           <a:xfrm>
-            <a:off x="8275320" y="2944368"/>
+            <a:off x="8275320" y="2852928"/>
             <a:ext cx="3108960" cy="365760"/>
           </a:xfrm>
           <a:prstGeom prst="rect">
@@ -5313,11 +5049,11 @@
             <a:r>
               <a:rPr sz="1100" b="0">
                 <a:solidFill>
-                  <a:srgbClr val="7D7767"/>
-                </a:solidFill>
-                <a:latin typeface="IBM Plex Mono"/>
-              </a:rPr>
-              <a:t>ROC AUC</a:t>
+                  <a:srgbClr val="5F6A66"/>
+                </a:solidFill>
+                <a:latin typeface="Arial"/>
+              </a:rPr>
+              <a:t>ROC AUC, fully answered</a:t>
             </a:r>
           </a:p>
         </p:txBody>
@@ -5330,7 +5066,7 @@
         </p:nvSpPr>
         <p:spPr>
           <a:xfrm>
-            <a:off x="8229600" y="3611880"/>
+            <a:off x="8229600" y="3474720"/>
             <a:ext cx="3108960" cy="640080"/>
           </a:xfrm>
           <a:prstGeom prst="rect">
@@ -5350,13 +5086,13 @@
               </a:spcAft>
             </a:pPr>
             <a:r>
-              <a:rPr sz="3400" b="0">
-                <a:solidFill>
-                  <a:srgbClr val="1F4B43"/>
-                </a:solidFill>
-                <a:latin typeface="Newsreader"/>
-              </a:rPr>
-              <a:t>67.7%</a:t>
+              <a:rPr sz="3400" b="1">
+                <a:solidFill>
+                  <a:srgbClr val="0B5D4B"/>
+                </a:solidFill>
+                <a:latin typeface="Arial"/>
+              </a:rPr>
+              <a:t>89%</a:t>
             </a:r>
           </a:p>
         </p:txBody>
@@ -5369,7 +5105,7 @@
         </p:nvSpPr>
         <p:spPr>
           <a:xfrm>
-            <a:off x="8275320" y="4178808"/>
+            <a:off x="8275320" y="4041648"/>
             <a:ext cx="3108960" cy="365760"/>
           </a:xfrm>
           <a:prstGeom prst="rect">
@@ -5391,11 +5127,11 @@
             <a:r>
               <a:rPr sz="1100" b="0">
                 <a:solidFill>
-                  <a:srgbClr val="7D7767"/>
-                </a:solidFill>
-                <a:latin typeface="IBM Plex Mono"/>
-              </a:rPr>
-              <a:t>recall</a:t>
+                  <a:srgbClr val="5F6A66"/>
+                </a:solidFill>
+                <a:latin typeface="Arial"/>
+              </a:rPr>
+              <a:t>of cleared claims accepted</a:t>
             </a:r>
           </a:p>
         </p:txBody>
@@ -5408,7 +5144,7 @@
         </p:nvSpPr>
         <p:spPr>
           <a:xfrm>
-            <a:off x="8229600" y="4846320"/>
+            <a:off x="8229600" y="4663440"/>
             <a:ext cx="3108960" cy="640080"/>
           </a:xfrm>
           <a:prstGeom prst="rect">
@@ -5428,13 +5164,13 @@
               </a:spcAft>
             </a:pPr>
             <a:r>
-              <a:rPr sz="3400" b="0">
-                <a:solidFill>
-                  <a:srgbClr val="1F4B43"/>
-                </a:solidFill>
-                <a:latin typeface="Newsreader"/>
-              </a:rPr>
-              <a:t>68 / 80%</a:t>
+              <a:rPr sz="3400" b="1">
+                <a:solidFill>
+                  <a:srgbClr val="0B5D4B"/>
+                </a:solidFill>
+                <a:latin typeface="Arial"/>
+              </a:rPr>
+              <a:t>72%</a:t>
             </a:r>
           </a:p>
         </p:txBody>
@@ -5447,7 +5183,7 @@
         </p:nvSpPr>
         <p:spPr>
           <a:xfrm>
-            <a:off x="8275320" y="5413248"/>
+            <a:off x="8275320" y="5230368"/>
             <a:ext cx="3108960" cy="365760"/>
           </a:xfrm>
           <a:prstGeom prst="rect">
@@ -5469,11 +5205,11 @@
             <a:r>
               <a:rPr sz="1100" b="0">
                 <a:solidFill>
-                  <a:srgbClr val="7D7767"/>
-                </a:solidFill>
-                <a:latin typeface="IBM Plex Mono"/>
-              </a:rPr>
-              <a:t>CARC top-1 / top-3</a:t>
+                  <a:srgbClr val="5F6A66"/>
+                </a:solidFill>
+                <a:latin typeface="Arial"/>
+              </a:rPr>
+              <a:t>of rejections flagged in advance</a:t>
             </a:r>
           </a:p>
         </p:txBody>
@@ -5486,7 +5222,7 @@
         </p:nvSpPr>
         <p:spPr>
           <a:xfrm>
-            <a:off x="822960" y="6035040"/>
+            <a:off x="822960" y="6080760"/>
             <a:ext cx="10515600" cy="365760"/>
           </a:xfrm>
           <a:prstGeom prst="rect">
@@ -5508,11 +5244,11 @@
             <a:r>
               <a:rPr sz="1100" b="0">
                 <a:solidFill>
-                  <a:srgbClr val="7D7767"/>
-                </a:solidFill>
-                <a:latin typeface="IBM Plex Mono"/>
-              </a:rPr>
-              <a:t>Held at 77.9% accuracy on purpose — see next slide</a:t>
+                  <a:srgbClr val="5F6A66"/>
+                </a:solidFill>
+                <a:latin typeface="Arial"/>
+              </a:rPr>
+              <a:t>Held-out test split, used once · low ≤ 23%, high ≥ 33%</a:t>
             </a:r>
           </a:p>
         </p:txBody>
@@ -5525,7 +5261,7 @@
         </p:nvSpPr>
         <p:spPr>
           <a:xfrm>
-            <a:off x="11247120" y="6035040"/>
+            <a:off x="11247120" y="6080760"/>
             <a:ext cx="548640" cy="365760"/>
           </a:xfrm>
           <a:prstGeom prst="rect">
@@ -5547,9 +5283,9 @@
             <a:r>
               <a:rPr sz="1100" b="0">
                 <a:solidFill>
-                  <a:srgbClr val="7D7767"/>
-                </a:solidFill>
-                <a:latin typeface="IBM Plex Mono"/>
+                  <a:srgbClr val="5F6A66"/>
+                </a:solidFill>
+                <a:latin typeface="Arial"/>
               </a:rPr>
               <a:t>6</a:t>
             </a:r>
@@ -5570,7 +5306,7 @@
     <p:bg>
       <p:bgPr>
         <a:solidFill>
-          <a:srgbClr val="FAF9F6"/>
+          <a:srgbClr val="F6F6F3"/>
         </a:solidFill>
         <a:effectLst/>
       </p:bgPr>
@@ -5610,11 +5346,11 @@
               </a:spcAft>
             </a:pPr>
             <a:r>
-              <a:rPr sz="1100" b="0">
-                <a:solidFill>
-                  <a:srgbClr val="7D7767"/>
-                </a:solidFill>
-                <a:latin typeface="IBM Plex Mono"/>
+              <a:rPr sz="1100" b="1">
+                <a:solidFill>
+                  <a:srgbClr val="0B5D4B"/>
+                </a:solidFill>
+                <a:latin typeface="Arial"/>
               </a:rPr>
               <a:t>THE DATA</a:t>
             </a:r>
@@ -5629,7 +5365,7 @@
         </p:nvSpPr>
         <p:spPr>
           <a:xfrm>
-            <a:off x="777240" y="960120"/>
+            <a:off x="777240" y="914400"/>
             <a:ext cx="10607040" cy="914400"/>
           </a:xfrm>
           <a:prstGeom prst="rect">
@@ -5649,11 +5385,11 @@
               </a:spcAft>
             </a:pPr>
             <a:r>
-              <a:rPr sz="3000" b="0">
-                <a:solidFill>
-                  <a:srgbClr val="17150F"/>
-                </a:solidFill>
-                <a:latin typeface="Newsreader"/>
+              <a:rPr sz="3200" b="0">
+                <a:solidFill>
+                  <a:srgbClr val="0E1412"/>
+                </a:solidFill>
+                <a:latin typeface="Georgia"/>
               </a:rPr>
               <a:t>No, the data is not real. It cannot be.</a:t>
             </a:r>
@@ -5676,7 +5412,7 @@
           </a:prstGeom>
           <a:ln w="9525">
             <a:solidFill>
-              <a:srgbClr val="E2DED2"/>
+              <a:srgbClr val="E1E3DD"/>
             </a:solidFill>
           </a:ln>
         </p:spPr>
@@ -5703,8 +5439,8 @@
         </p:nvSpPr>
         <p:spPr>
           <a:xfrm>
-            <a:off x="822960" y="2286000"/>
-            <a:ext cx="6949440" cy="3291840"/>
+            <a:off x="822960" y="2240280"/>
+            <a:ext cx="6949440" cy="3566160"/>
           </a:xfrm>
           <a:prstGeom prst="rect">
             <a:avLst/>
@@ -5725,11 +5461,11 @@
             <a:r>
               <a:rPr sz="1500">
                 <a:solidFill>
-                  <a:srgbClr val="4A463B"/>
-                </a:solidFill>
-                <a:latin typeface="IBM Plex Sans"/>
-              </a:rPr>
-              <a:t>No public dataset exists anywhere of real clinic claims paired with</a:t>
+                  <a:srgbClr val="3E4945"/>
+                </a:solidFill>
+                <a:latin typeface="Arial"/>
+              </a:rPr>
+              <a:t>No public dataset exists anywhere of real clinic claims paired with their outcomes. Insurers treat that as private business information.</a:t>
             </a:r>
           </a:p>
           <a:p>
@@ -5738,14 +5474,21 @@
                 <a:spcPts val="300"/>
               </a:spcAft>
             </a:pPr>
+          </a:p>
+          <a:p>
+            <a:pPr>
+              <a:spcAft>
+                <a:spcPts val="300"/>
+              </a:spcAft>
+            </a:pPr>
             <a:r>
               <a:rPr sz="1500">
                 <a:solidFill>
-                  <a:srgbClr val="4A463B"/>
-                </a:solidFill>
-                <a:latin typeface="IBM Plex Sans"/>
-              </a:rPr>
-              <a:t>their outcomes. Insurers treat that as private business information.</a:t>
+                  <a:srgbClr val="3E4945"/>
+                </a:solidFill>
+                <a:latin typeface="Arial"/>
+              </a:rPr>
+              <a:t>So we built ours from two real pieces:</a:t>
             </a:r>
           </a:p>
           <a:p>
@@ -5757,11 +5500,11 @@
             <a:r>
               <a:rPr sz="1500">
                 <a:solidFill>
-                  <a:srgbClr val="4A463B"/>
-                </a:solidFill>
-                <a:latin typeface="IBM Plex Sans"/>
-              </a:rPr>
-              <a:t>Every commercial product here trains on its own private history.</a:t>
+                  <a:srgbClr val="3E4945"/>
+                </a:solidFill>
+                <a:latin typeface="Arial"/>
+              </a:rPr>
+              <a:t>Synthea — open clinical simulator, real SNOMED CT codes</a:t>
             </a:r>
           </a:p>
           <a:p>
@@ -5770,6 +5513,15 @@
                 <a:spcPts val="300"/>
               </a:spcAft>
             </a:pPr>
+            <a:r>
+              <a:rPr sz="1500">
+                <a:solidFill>
+                  <a:srgbClr val="3E4945"/>
+                </a:solidFill>
+                <a:latin typeface="Arial"/>
+              </a:rPr>
+              <a:t>X12 CARC — the real industry rejection-reason standard</a:t>
+            </a:r>
           </a:p>
           <a:p>
             <a:pPr>
@@ -5777,101 +5529,21 @@
                 <a:spcPts val="300"/>
               </a:spcAft>
             </a:pPr>
+          </a:p>
+          <a:p>
+            <a:pPr>
+              <a:spcAft>
+                <a:spcPts val="300"/>
+              </a:spcAft>
+            </a:pPr>
             <a:r>
               <a:rPr sz="1500">
                 <a:solidFill>
-                  <a:srgbClr val="4A463B"/>
-                </a:solidFill>
-                <a:latin typeface="IBM Plex Sans"/>
-              </a:rPr>
-              <a:t>So we built ours from two real pieces:</a:t>
-            </a:r>
-          </a:p>
-          <a:p>
-            <a:pPr>
-              <a:spcAft>
-                <a:spcPts val="300"/>
-              </a:spcAft>
-            </a:pPr>
-            <a:r>
-              <a:rPr sz="1500">
-                <a:solidFill>
-                  <a:srgbClr val="4A463B"/>
-                </a:solidFill>
-                <a:latin typeface="IBM Plex Sans"/>
-              </a:rPr>
-              <a:t>     Synthea — open clinical simulator, real SNOMED CT codes</a:t>
-            </a:r>
-          </a:p>
-          <a:p>
-            <a:pPr>
-              <a:spcAft>
-                <a:spcPts val="300"/>
-              </a:spcAft>
-            </a:pPr>
-            <a:r>
-              <a:rPr sz="1500">
-                <a:solidFill>
-                  <a:srgbClr val="4A463B"/>
-                </a:solidFill>
-                <a:latin typeface="IBM Plex Sans"/>
-              </a:rPr>
-              <a:t>     X12 CARC — the real industry rejection-reason standard</a:t>
-            </a:r>
-          </a:p>
-          <a:p>
-            <a:pPr>
-              <a:spcAft>
-                <a:spcPts val="300"/>
-              </a:spcAft>
-            </a:pPr>
-          </a:p>
-          <a:p>
-            <a:pPr>
-              <a:spcAft>
-                <a:spcPts val="300"/>
-              </a:spcAft>
-            </a:pPr>
-            <a:r>
-              <a:rPr sz="1500">
-                <a:solidFill>
-                  <a:srgbClr val="4A463B"/>
-                </a:solidFill>
-                <a:latin typeface="IBM Plex Sans"/>
-              </a:rPr>
-              <a:t>Only the labelling logic is ours, and we documented exactly where</a:t>
-            </a:r>
-          </a:p>
-          <a:p>
-            <a:pPr>
-              <a:spcAft>
-                <a:spcPts val="300"/>
-              </a:spcAft>
-            </a:pPr>
-            <a:r>
-              <a:rPr sz="1500">
-                <a:solidFill>
-                  <a:srgbClr val="4A463B"/>
-                </a:solidFill>
-                <a:latin typeface="IBM Plex Sans"/>
-              </a:rPr>
-              <a:t>that line falls. A near-perfect score on self-generated data would</a:t>
-            </a:r>
-          </a:p>
-          <a:p>
-            <a:pPr>
-              <a:spcAft>
-                <a:spcPts val="300"/>
-              </a:spcAft>
-            </a:pPr>
-            <a:r>
-              <a:rPr sz="1500">
-                <a:solidFill>
-                  <a:srgbClr val="4A463B"/>
-                </a:solidFill>
-                <a:latin typeface="IBM Plex Sans"/>
-              </a:rPr>
-              <a:t>only prove the model memorised our own rules.</a:t>
+                  <a:srgbClr val="3E4945"/>
+                </a:solidFill>
+                <a:latin typeface="Arial"/>
+              </a:rPr>
+              <a:t>Only the labelling logic is ours, and it is written down. A near-perfect score on self-generated data would only prove the model had memorised our rules.</a:t>
             </a:r>
           </a:p>
         </p:txBody>
@@ -5884,7 +5556,7 @@
         </p:nvSpPr>
         <p:spPr>
           <a:xfrm>
-            <a:off x="822960" y="6035040"/>
+            <a:off x="822960" y="6080760"/>
             <a:ext cx="10515600" cy="365760"/>
           </a:xfrm>
           <a:prstGeom prst="rect">
@@ -5906,9 +5578,9 @@
             <a:r>
               <a:rPr sz="1100" b="0">
                 <a:solidFill>
-                  <a:srgbClr val="7D7767"/>
-                </a:solidFill>
-                <a:latin typeface="IBM Plex Mono"/>
+                  <a:srgbClr val="5F6A66"/>
+                </a:solidFill>
+                <a:latin typeface="Arial"/>
               </a:rPr>
               <a:t>docs/data-provenance.md · docs/model-card.md</a:t>
             </a:r>
@@ -5923,7 +5595,7 @@
         </p:nvSpPr>
         <p:spPr>
           <a:xfrm>
-            <a:off x="11247120" y="6035040"/>
+            <a:off x="11247120" y="6080760"/>
             <a:ext cx="548640" cy="365760"/>
           </a:xfrm>
           <a:prstGeom prst="rect">
@@ -5945,9 +5617,9 @@
             <a:r>
               <a:rPr sz="1100" b="0">
                 <a:solidFill>
-                  <a:srgbClr val="7D7767"/>
-                </a:solidFill>
-                <a:latin typeface="IBM Plex Mono"/>
+                  <a:srgbClr val="5F6A66"/>
+                </a:solidFill>
+                <a:latin typeface="Arial"/>
               </a:rPr>
               <a:t>7</a:t>
             </a:r>
@@ -5968,7 +5640,7 @@
     <p:bg>
       <p:bgPr>
         <a:solidFill>
-          <a:srgbClr val="FAF9F6"/>
+          <a:srgbClr val="F6F6F3"/>
         </a:solidFill>
         <a:effectLst/>
       </p:bgPr>
@@ -6008,13 +5680,13 @@
               </a:spcAft>
             </a:pPr>
             <a:r>
-              <a:rPr sz="1100" b="0">
-                <a:solidFill>
-                  <a:srgbClr val="7D7767"/>
-                </a:solidFill>
-                <a:latin typeface="IBM Plex Mono"/>
-              </a:rPr>
-              <a:t>THE LOOP</a:t>
+              <a:rPr sz="1100" b="1">
+                <a:solidFill>
+                  <a:srgbClr val="0B5D4B"/>
+                </a:solidFill>
+                <a:latin typeface="Arial"/>
+              </a:rPr>
+              <a:t>BUILT TO BE CHECKED</a:t>
             </a:r>
           </a:p>
         </p:txBody>
@@ -6027,7 +5699,7 @@
         </p:nvSpPr>
         <p:spPr>
           <a:xfrm>
-            <a:off x="777240" y="960120"/>
+            <a:off x="777240" y="914400"/>
             <a:ext cx="10607040" cy="914400"/>
           </a:xfrm>
           <a:prstGeom prst="rect">
@@ -6047,13 +5719,13 @@
               </a:spcAft>
             </a:pPr>
             <a:r>
-              <a:rPr sz="3000" b="0">
-                <a:solidFill>
-                  <a:srgbClr val="17150F"/>
-                </a:solidFill>
-                <a:latin typeface="Newsreader"/>
-              </a:rPr>
-              <a:t>Honest about self-improvement</a:t>
+              <a:rPr sz="3200" b="0">
+                <a:solidFill>
+                  <a:srgbClr val="0E1412"/>
+                </a:solidFill>
+                <a:latin typeface="Georgia"/>
+              </a:rPr>
+              <a:t>Reproducible, and audited</a:t>
             </a:r>
           </a:p>
         </p:txBody>
@@ -6074,7 +5746,7 @@
           </a:prstGeom>
           <a:ln w="9525">
             <a:solidFill>
-              <a:srgbClr val="E2DED2"/>
+              <a:srgbClr val="E1E3DD"/>
             </a:solidFill>
           </a:ln>
         </p:spPr>
@@ -6101,8 +5773,8 @@
         </p:nvSpPr>
         <p:spPr>
           <a:xfrm>
-            <a:off x="822960" y="2286000"/>
-            <a:ext cx="6949440" cy="3291840"/>
+            <a:off x="822960" y="2240280"/>
+            <a:ext cx="6949440" cy="3566160"/>
           </a:xfrm>
           <a:prstGeom prst="rect">
             <a:avLst/>
@@ -6123,11 +5795,11 @@
             <a:r>
               <a:rPr sz="1500">
                 <a:solidFill>
-                  <a:srgbClr val="4A463B"/>
-                </a:solidFill>
-                <a:latin typeface="IBM Plex Sans"/>
-              </a:rPr>
-              <a:t>When staff disagree, one click logs the correction as a labelled</a:t>
+                  <a:srgbClr val="3E4945"/>
+                </a:solidFill>
+                <a:latin typeface="Arial"/>
+              </a:rPr>
+              <a:t>The dataset builds byte-for-byte from a checksum-pinned Synthea bundle; CI rebuilds it weekly and fails on any drift.</a:t>
             </a:r>
           </a:p>
           <a:p>
@@ -6136,14 +5808,21 @@
                 <a:spcPts val="300"/>
               </a:spcAft>
             </a:pPr>
+          </a:p>
+          <a:p>
+            <a:pPr>
+              <a:spcAft>
+                <a:spcPts val="300"/>
+              </a:spcAft>
+            </a:pPr>
             <a:r>
               <a:rPr sz="1500">
                 <a:solidFill>
-                  <a:srgbClr val="4A463B"/>
-                </a:solidFill>
-                <a:latin typeface="IBM Plex Sans"/>
-              </a:rPr>
-              <a:t>example. That is all it does, and we say so.</a:t>
+                  <a:srgbClr val="3E4945"/>
+                </a:solidFill>
+                <a:latin typeface="Arial"/>
+              </a:rPr>
+              <a:t>Hyperparameters chosen by cross-validation, bands on validation, the test split reported once — as the verdicts users would get.</a:t>
             </a:r>
           </a:p>
           <a:p>
@@ -6162,82 +5841,11 @@
             <a:r>
               <a:rPr sz="1500">
                 <a:solidFill>
-                  <a:srgbClr val="4A463B"/>
-                </a:solidFill>
-                <a:latin typeface="IBM Plex Sans"/>
-              </a:rPr>
-              <a:t>Real products close this loop by parsing the 835 remittance files</a:t>
-            </a:r>
-          </a:p>
-          <a:p>
-            <a:pPr>
-              <a:spcAft>
-                <a:spcPts val="300"/>
-              </a:spcAft>
-            </a:pPr>
-            <a:r>
-              <a:rPr sz="1500">
-                <a:solidFill>
-                  <a:srgbClr val="4A463B"/>
-                </a:solidFill>
-                <a:latin typeface="IBM Plex Sans"/>
-              </a:rPr>
-              <a:t>insurers return, retraining as outcomes accumulate over weeks.</a:t>
-            </a:r>
-          </a:p>
-          <a:p>
-            <a:pPr>
-              <a:spcAft>
-                <a:spcPts val="300"/>
-              </a:spcAft>
-            </a:pPr>
-            <a:r>
-              <a:rPr sz="1500">
-                <a:solidFill>
-                  <a:srgbClr val="4A463B"/>
-                </a:solidFill>
-                <a:latin typeface="IBM Plex Sans"/>
-              </a:rPr>
-              <a:t>Nobody in this industry has live self-improvement.</a:t>
-            </a:r>
-          </a:p>
-          <a:p>
-            <a:pPr>
-              <a:spcAft>
-                <a:spcPts val="300"/>
-              </a:spcAft>
-            </a:pPr>
-          </a:p>
-          <a:p>
-            <a:pPr>
-              <a:spcAft>
-                <a:spcPts val="300"/>
-              </a:spcAft>
-            </a:pPr>
-            <a:r>
-              <a:rPr sz="1500">
-                <a:solidFill>
-                  <a:srgbClr val="4A463B"/>
-                </a:solidFill>
-                <a:latin typeface="IBM Plex Sans"/>
-              </a:rPr>
-              <a:t>Our architecture supports that path. The demo does not pretend to</a:t>
-            </a:r>
-          </a:p>
-          <a:p>
-            <a:pPr>
-              <a:spcAft>
-                <a:spcPts val="300"/>
-              </a:spcAft>
-            </a:pPr>
-            <a:r>
-              <a:rPr sz="1500">
-                <a:solidFill>
-                  <a:srgbClr val="4A463B"/>
-                </a:solidFill>
-                <a:latin typeface="IBM Plex Sans"/>
-              </a:rPr>
-              <a:t>have walked it.</a:t>
+                  <a:srgbClr val="3E4945"/>
+                </a:solidFill>
+                <a:latin typeface="Arial"/>
+              </a:rPr>
+              <a:t>An independent audit's findings are fixed and pinned by tests: input validation, verdict gating, attribution that adds up, and an explanation layer that cannot state a number it was not given.</a:t>
             </a:r>
           </a:p>
         </p:txBody>
@@ -6250,8 +5858,8 @@
         </p:nvSpPr>
         <p:spPr>
           <a:xfrm>
-            <a:off x="11247120" y="6035040"/>
-            <a:ext cx="548640" cy="365760"/>
+            <a:off x="822960" y="6080760"/>
+            <a:ext cx="10515600" cy="365760"/>
           </a:xfrm>
           <a:prstGeom prst="rect">
             <a:avLst/>
@@ -6272,9 +5880,48 @@
             <a:r>
               <a:rPr sz="1100" b="0">
                 <a:solidFill>
-                  <a:srgbClr val="7D7767"/>
-                </a:solidFill>
-                <a:latin typeface="IBM Plex Mono"/>
+                  <a:srgbClr val="5F6A66"/>
+                </a:solidFill>
+                <a:latin typeface="Arial"/>
+              </a:rPr>
+              <a:t>When staff disagree, one click logs a labelled correction. Nothing retrains live.</a:t>
+            </a:r>
+          </a:p>
+        </p:txBody>
+      </p:sp>
+      <p:sp>
+        <p:nvSpPr>
+          <p:cNvPr id="7" name="TextBox 6"/>
+          <p:cNvSpPr txBox="1"/>
+          <p:nvPr/>
+        </p:nvSpPr>
+        <p:spPr>
+          <a:xfrm>
+            <a:off x="11247120" y="6080760"/>
+            <a:ext cx="548640" cy="365760"/>
+          </a:xfrm>
+          <a:prstGeom prst="rect">
+            <a:avLst/>
+          </a:prstGeom>
+          <a:noFill/>
+        </p:spPr>
+        <p:txBody>
+          <a:bodyPr wrap="none">
+            <a:spAutoFit/>
+          </a:bodyPr>
+          <a:lstStyle/>
+          <a:p>
+            <a:pPr algn="l">
+              <a:spcAft>
+                <a:spcPts val="0"/>
+              </a:spcAft>
+            </a:pPr>
+            <a:r>
+              <a:rPr sz="1100" b="0">
+                <a:solidFill>
+                  <a:srgbClr val="5F6A66"/>
+                </a:solidFill>
+                <a:latin typeface="Arial"/>
               </a:rPr>
               <a:t>8</a:t>
             </a:r>
@@ -6295,7 +5942,7 @@
     <p:bg>
       <p:bgPr>
         <a:solidFill>
-          <a:srgbClr val="FAF9F6"/>
+          <a:srgbClr val="F6F6F3"/>
         </a:solidFill>
         <a:effectLst/>
       </p:bgPr>
@@ -6335,11 +5982,11 @@
               </a:spcAft>
             </a:pPr>
             <a:r>
-              <a:rPr sz="1100" b="0">
-                <a:solidFill>
-                  <a:srgbClr val="7D7767"/>
-                </a:solidFill>
-                <a:latin typeface="IBM Plex Mono"/>
+              <a:rPr sz="1100" b="1">
+                <a:solidFill>
+                  <a:srgbClr val="0B5D4B"/>
+                </a:solidFill>
+                <a:latin typeface="Arial"/>
               </a:rPr>
               <a:t>WHAT'S NEXT</a:t>
             </a:r>
@@ -6354,7 +6001,7 @@
         </p:nvSpPr>
         <p:spPr>
           <a:xfrm>
-            <a:off x="777240" y="960120"/>
+            <a:off x="777240" y="914400"/>
             <a:ext cx="10607040" cy="914400"/>
           </a:xfrm>
           <a:prstGeom prst="rect">
@@ -6374,11 +6021,11 @@
               </a:spcAft>
             </a:pPr>
             <a:r>
-              <a:rPr sz="3000" b="0">
-                <a:solidFill>
-                  <a:srgbClr val="17150F"/>
-                </a:solidFill>
-                <a:latin typeface="Newsreader"/>
+              <a:rPr sz="3200" b="0">
+                <a:solidFill>
+                  <a:srgbClr val="0E1412"/>
+                </a:solidFill>
+                <a:latin typeface="Georgia"/>
               </a:rPr>
               <a:t>What production would need</a:t>
             </a:r>
@@ -6401,7 +6048,7 @@
           </a:prstGeom>
           <a:ln w="9525">
             <a:solidFill>
-              <a:srgbClr val="E2DED2"/>
+              <a:srgbClr val="E1E3DD"/>
             </a:solidFill>
           </a:ln>
         </p:spPr>
@@ -6428,8 +6075,8 @@
         </p:nvSpPr>
         <p:spPr>
           <a:xfrm>
-            <a:off x="822960" y="2286000"/>
-            <a:ext cx="6949440" cy="3291840"/>
+            <a:off x="822960" y="2240280"/>
+            <a:ext cx="6949440" cy="3566160"/>
           </a:xfrm>
           <a:prstGeom prst="rect">
             <a:avLst/>
@@ -6450,11 +6097,11 @@
             <a:r>
               <a:rPr sz="1500">
                 <a:solidFill>
-                  <a:srgbClr val="4A463B"/>
-                </a:solidFill>
-                <a:latin typeface="IBM Plex Sans"/>
-              </a:rPr>
-              <a:t>1.  Real historical claims with real adjudication outcomes, from a</a:t>
+                  <a:srgbClr val="3E4945"/>
+                </a:solidFill>
+                <a:latin typeface="Arial"/>
+              </a:rPr>
+              <a:t>1.  Real historical claims with real adjudication outcomes, from a partner clinic or TPA</a:t>
             </a:r>
           </a:p>
           <a:p>
@@ -6466,11 +6113,11 @@
             <a:r>
               <a:rPr sz="1500">
                 <a:solidFill>
-                  <a:srgbClr val="4A463B"/>
-                </a:solidFill>
-                <a:latin typeface="IBM Plex Sans"/>
-              </a:rPr>
-              <a:t>     partner clinic or TPA</a:t>
+                  <a:srgbClr val="3E4945"/>
+                </a:solidFill>
+                <a:latin typeface="Arial"/>
+              </a:rPr>
+              <a:t>2.  Parsed 835 remittance advice, for the codes insurers actually sent</a:t>
             </a:r>
           </a:p>
           <a:p>
@@ -6482,11 +6129,11 @@
             <a:r>
               <a:rPr sz="1500">
                 <a:solidFill>
-                  <a:srgbClr val="4A463B"/>
-                </a:solidFill>
-                <a:latin typeface="IBM Plex Sans"/>
-              </a:rPr>
-              <a:t>2.  Parsed 835 remittance advice, for the codes insurers actually sent</a:t>
+                  <a:srgbClr val="3E4945"/>
+                </a:solidFill>
+                <a:latin typeface="Arial"/>
+              </a:rPr>
+              <a:t>3.  Retraining as outcomes accumulate, with human corrections as labels</a:t>
             </a:r>
           </a:p>
           <a:p>
@@ -6498,11 +6145,11 @@
             <a:r>
               <a:rPr sz="1500">
                 <a:solidFill>
-                  <a:srgbClr val="4A463B"/>
-                </a:solidFill>
-                <a:latin typeface="IBM Plex Sans"/>
-              </a:rPr>
-              <a:t>3.  Retraining as outcomes accumulate, with human corrections as labels</a:t>
+                  <a:srgbClr val="3E4945"/>
+                </a:solidFill>
+                <a:latin typeface="Arial"/>
+              </a:rPr>
+              <a:t>4.  Per-insurer models and rule tables — they differ by payer</a:t>
             </a:r>
           </a:p>
           <a:p>
@@ -6511,35 +6158,19 @@
                 <a:spcPts val="300"/>
               </a:spcAft>
             </a:pPr>
+          </a:p>
+          <a:p>
+            <a:pPr>
+              <a:spcAft>
+                <a:spcPts val="300"/>
+              </a:spcAft>
+            </a:pPr>
             <a:r>
               <a:rPr sz="1500">
                 <a:solidFill>
-                  <a:srgbClr val="4A463B"/>
-                </a:solidFill>
-                <a:latin typeface="IBM Plex Sans"/>
-              </a:rPr>
-              <a:t>4.  Per-insurer models — filing rules and tariffs differ by payer</a:t>
-            </a:r>
-          </a:p>
-          <a:p>
-            <a:pPr>
-              <a:spcAft>
-                <a:spcPts val="300"/>
-              </a:spcAft>
-            </a:pPr>
-          </a:p>
-          <a:p>
-            <a:pPr>
-              <a:spcAft>
-                <a:spcPts val="300"/>
-              </a:spcAft>
-            </a:pPr>
-            <a:r>
-              <a:rPr sz="1500">
-                <a:solidFill>
-                  <a:srgbClr val="4A463B"/>
-                </a:solidFill>
-                <a:latin typeface="IBM Plex Sans"/>
+                  <a:srgbClr val="3E4945"/>
+                </a:solidFill>
+                <a:latin typeface="Arial"/>
               </a:rPr>
               <a:t>The system supports all four. It cannot access the data they need.</a:t>
             </a:r>
@@ -6554,7 +6185,7 @@
         </p:nvSpPr>
         <p:spPr>
           <a:xfrm>
-            <a:off x="822960" y="6035040"/>
+            <a:off x="822960" y="6080760"/>
             <a:ext cx="10515600" cy="365760"/>
           </a:xfrm>
           <a:prstGeom prst="rect">
@@ -6576,11 +6207,11 @@
             <a:r>
               <a:rPr sz="1100" b="0">
                 <a:solidFill>
-                  <a:srgbClr val="7D7767"/>
-                </a:solidFill>
-                <a:latin typeface="IBM Plex Mono"/>
-              </a:rPr>
-              <a:t>Python · LightGBM · SHAP · FastAPI · Next.js · Qwen on DashScope · containerised, ECS runbook</a:t>
+                  <a:srgbClr val="5F6A66"/>
+                </a:solidFill>
+                <a:latin typeface="Arial"/>
+              </a:rPr>
+              <a:t>Python · LightGBM · FastAPI · Next.js · Qwen on DashScope · containerised</a:t>
             </a:r>
           </a:p>
         </p:txBody>
@@ -6593,7 +6224,7 @@
         </p:nvSpPr>
         <p:spPr>
           <a:xfrm>
-            <a:off x="11247120" y="6035040"/>
+            <a:off x="11247120" y="6080760"/>
             <a:ext cx="548640" cy="365760"/>
           </a:xfrm>
           <a:prstGeom prst="rect">
@@ -6615,9 +6246,9 @@
             <a:r>
               <a:rPr sz="1100" b="0">
                 <a:solidFill>
-                  <a:srgbClr val="7D7767"/>
-                </a:solidFill>
-                <a:latin typeface="IBM Plex Mono"/>
+                  <a:srgbClr val="5F6A66"/>
+                </a:solidFill>
+                <a:latin typeface="Arial"/>
               </a:rPr>
               <a:t>9</a:t>
             </a:r>

</xml_diff>

<commit_message>
docs: refresh figures, deck and screenshots after the review fixes, and record the new rules
</commit_message>
<xml_diff>
--- a/docs/deck.pptx
+++ b/docs/deck.pptx
@@ -4230,7 +4230,7 @@
                 </a:solidFill>
                 <a:latin typeface="Arial"/>
               </a:rPr>
-              <a:t>52</a:t>
+              <a:t>55</a:t>
             </a:r>
           </a:p>
         </p:txBody>
@@ -4308,7 +4308,7 @@
                 </a:solidFill>
                 <a:latin typeface="Arial"/>
               </a:rPr>
-              <a:t>3.5</a:t>
+              <a:t>3.6</a:t>
             </a:r>
           </a:p>
         </p:txBody>
@@ -4975,7 +4975,7 @@
                 </a:solidFill>
                 <a:latin typeface="Arial"/>
               </a:rPr>
-              <a:t>Claims cleared as low risk: 62% of all, 89% of them accepted. Claims flagged high: 26% of all, 56% of them rejected. Accuracy at the high-risk line: 81.8%. Reason code: 88% top-1 across 12 real codes.</a:t>
+              <a:t>Claims cleared as low risk: 63% of all, 89% of them accepted. Claims flagged high: 26% of all, 56% of them rejected. Accuracy at the high-risk line: 81.8%. Reason code: 83% top-1 across 13 real codes.</a:t>
             </a:r>
           </a:p>
         </p:txBody>

</xml_diff>

<commit_message>
docs: refresh screenshots and both decks for document reading
</commit_message>
<xml_diff>
--- a/docs/deck.pptx
+++ b/docs/deck.pptx
@@ -3759,7 +3759,7 @@
                 </a:solidFill>
                 <a:latin typeface="Georgia"/>
               </a:rPr>
-              <a:t>Enter the bill. Answer what matters.</a:t>
+              <a:t>Read the papers. Ask what matters.</a:t>
             </a:r>
           </a:p>
         </p:txBody>
@@ -3833,7 +3833,7 @@
                 </a:solidFill>
                 <a:latin typeface="Arial"/>
               </a:rPr>
-              <a:t>1.  The clerk enters the patient and the bill: procedure and amount.</a:t>
+              <a:t>1.  The clerk photographs the bill and its papers, and Qwen-VL reads what is printed on them; the clerk confirms every value (or types the bill instead).</a:t>
             </a:r>
           </a:p>
           <a:p>
@@ -3849,7 +3849,7 @@
                 </a:solidFill>
                 <a:latin typeface="Arial"/>
               </a:rPr>
-              <a:t>2.  The tool asks only the paperwork questions that matter for this claim, choosing each by expected information gain.</a:t>
+              <a:t>2.  The tool asks only the questions the papers cannot settle, choosing each by expected information gain.</a:t>
             </a:r>
           </a:p>
           <a:p>
@@ -3895,7 +3895,7 @@
       </p:sp>
       <p:pic>
         <p:nvPicPr>
-          <p:cNvPr id="6" name="Picture 5" descr="check.png"/>
+          <p:cNvPr id="6" name="Picture 5" descr="documents.png"/>
           <p:cNvPicPr>
             <a:picLocks noChangeAspect="1"/>
           </p:cNvPicPr>
@@ -3951,7 +3951,7 @@
                 </a:solidFill>
                 <a:latin typeface="Arial"/>
               </a:rPr>
-              <a:t>Calibrated LightGBM · exact Shapley attribution · Qwen on Alibaba Cloud DashScope</a:t>
+              <a:t>Calibrated LightGBM · exact Shapley attribution · Qwen and Qwen-VL on Alibaba Cloud DashScope</a:t>
             </a:r>
           </a:p>
         </p:txBody>
@@ -4688,7 +4688,7 @@
                 </a:solidFill>
                 <a:latin typeface="Arial"/>
               </a:rPr>
-              <a:t>Rule checks say what the clerk may not know: whether pre-approval was needed, how much of the filing window is left.</a:t>
+              <a:t>Rule checks say what the clerk may not know: whether pre-approval was needed, how much of the filing window is left, and whether the papers agree — an approval for less than was billed, a missing one.</a:t>
             </a:r>
           </a:p>
           <a:p>

</xml_diff>